<commit_message>
Credits: Dave Justin Ll. De Asis as lead researcher, add support group
Co-Authored-By: Claude Opus 5.5 <noreply@anthropic.com>
Claude-Session: https://claude.ai/code/session_01L2hthenQG1mBGNzjn6dooT
</commit_message>
<xml_diff>
--- a/docs/downloads/BUHAY-AH-PR2-Introduction-Methodology.pptx
+++ b/docs/downloads/BUHAY-AH-PR2-Introduction-Methodology.pptx
@@ -3380,8 +3380,8 @@
         </p:nvSpPr>
         <p:spPr>
           <a:xfrm rot="0">
-            <a:off x="4169007" y="7583666"/>
-            <a:ext cx="9949987" cy="690727"/>
+            <a:off x="3319272" y="7269480"/>
+            <a:ext cx="11649456" cy="1280160"/>
           </a:xfrm>
           <a:prstGeom prst="rect">
             <a:avLst/>
@@ -3399,7 +3399,7 @@
               </a:lnSpc>
             </a:pPr>
             <a:r>
-              <a:rPr lang="en-US" sz="4795">
+              <a:rPr lang="en-US" sz="2400">
                 <a:solidFill>
                   <a:srgbClr val="FFFFFF"/>
                 </a:solidFill>
@@ -3408,7 +3408,26 @@
                 <a:cs typeface="ITC Avant Garde Gothic"/>
                 <a:sym typeface="ITC Avant Garde Gothic"/>
               </a:rPr>
-              <a:t>Enrique Miguel C. Buban (Lead) · Peter John A. Brimbuela · Dave Justin Ll. De Asis · Yeaseong Shin</a:t>
+              <a:t>Dave Justin Ll. De Asis · Lead Researcher</a:t>
+            </a:r>
+          </a:p>
+          <a:p>
+            <a:pPr algn="ctr">
+              <a:lnSpc>
+                <a:spcPts val="4315"/>
+              </a:lnSpc>
+            </a:pPr>
+            <a:r>
+              <a:rPr lang="en-US" sz="1800">
+                <a:solidFill>
+                  <a:srgbClr val="FFFFFF"/>
+                </a:solidFill>
+                <a:latin typeface="ITC Avant Garde Gothic"/>
+                <a:ea typeface="ITC Avant Garde Gothic"/>
+                <a:cs typeface="ITC Avant Garde Gothic"/>
+                <a:sym typeface="ITC Avant Garde Gothic"/>
+              </a:rPr>
+              <a:t>Researchers: Peter John A. Brimbuela, Yeaseong Shin  ·  Support group: Yuriel</a:t>
             </a:r>
           </a:p>
         </p:txBody>

</xml_diff>

<commit_message>
Remove CORA citation; fix Q&A slide title wrap
Co-Authored-By: Claude Opus 5.5 <noreply@anthropic.com>
Claude-Session: https://claude.ai/code/session_01L2hthenQG1mBGNzjn6dooT
</commit_message>
<xml_diff>
--- a/docs/downloads/BUHAY-AH-PR2-Introduction-Methodology.pptx
+++ b/docs/downloads/BUHAY-AH-PR2-Introduction-Methodology.pptx
@@ -5146,7 +5146,7 @@
         </p:nvGraphicFramePr>
         <p:xfrm>
           <a:off x="731520" y="2103120"/>
-          <a:ext cx="16824960" cy="7077456"/>
+          <a:ext cx="16824960" cy="6291072"/>
         </p:xfrm>
         <a:graphic>
           <a:graphicData uri="http://schemas.openxmlformats.org/drawingml/2006/table">
@@ -5713,7 +5713,7 @@
                           </a:solidFill>
                           <a:latin typeface="ITC Avant Garde Gothic"/>
                         </a:rPr>
-                        <a:t>Buban (2026), CORA</a:t>
+                        <a:t>GAO (2020)</a:t>
                       </a:r>
                     </a:p>
                   </a:txBody>
@@ -5735,7 +5735,7 @@
                           </a:solidFill>
                           <a:latin typeface="ITC Avant Garde Gothic"/>
                         </a:rPr>
-                        <a:t>MLR + XGBoost + IF</a:t>
+                        <a:t>Should-cost estimating</a:t>
                       </a:r>
                     </a:p>
                   </a:txBody>
@@ -5757,7 +5757,7 @@
                           </a:solidFill>
                           <a:latin typeface="ITC Avant Garde Gothic"/>
                         </a:rPr>
-                        <a:t>R² 0.8723, MAPE 29.20%</a:t>
+                        <a:t>Bottom-up fair price</a:t>
                       </a:r>
                     </a:p>
                   </a:txBody>
@@ -5779,7 +5779,7 @@
                           </a:solidFill>
                           <a:latin typeface="ITC Avant Garde Gothic"/>
                         </a:rPr>
-                        <a:t>Recall unknown</a:t>
+                        <a:t>No open tool</a:t>
                       </a:r>
                     </a:p>
                   </a:txBody>
@@ -5803,7 +5803,7 @@
                           </a:solidFill>
                           <a:latin typeface="ITC Avant Garde Gothic"/>
                         </a:rPr>
-                        <a:t>GAO (2020)</a:t>
+                        <a:t>ICAO (2022); OCDI (2009)</a:t>
                       </a:r>
                     </a:p>
                   </a:txBody>
@@ -5825,7 +5825,7 @@
                           </a:solidFill>
                           <a:latin typeface="ITC Avant Garde Gothic"/>
                         </a:rPr>
-                        <a:t>Should-cost estimating</a:t>
+                        <a:t>Aerodrome / port standards</a:t>
                       </a:r>
                     </a:p>
                   </a:txBody>
@@ -5847,7 +5847,7 @@
                           </a:solidFill>
                           <a:latin typeface="ITC Avant Garde Gothic"/>
                         </a:rPr>
-                        <a:t>Bottom-up fair price</a:t>
+                        <a:t>Runway, pier rules</a:t>
                       </a:r>
                     </a:p>
                   </a:txBody>
@@ -5869,103 +5869,13 @@
                           </a:solidFill>
                           <a:latin typeface="ITC Avant Garde Gothic"/>
                         </a:rPr>
-                        <a:t>No open tool</a:t>
+                        <a:t>Not priced</a:t>
                       </a:r>
                     </a:p>
                   </a:txBody>
                   <a:tcPr marL="91440" marR="91440">
                     <a:solidFill>
                       <a:srgbClr val="7A0606"/>
-                    </a:solidFill>
-                  </a:tcPr>
-                </a:tc>
-              </a:tr>
-              <a:tr h="786384">
-                <a:tc>
-                  <a:txBody>
-                    <a:bodyPr/>
-                    <a:lstStyle/>
-                    <a:p>
-                      <a:r>
-                        <a:rPr sz="2100" b="0">
-                          <a:solidFill>
-                            <a:srgbClr val="FFFFFF"/>
-                          </a:solidFill>
-                          <a:latin typeface="ITC Avant Garde Gothic"/>
-                        </a:rPr>
-                        <a:t>ICAO (2022); OCDI (2009)</a:t>
-                      </a:r>
-                    </a:p>
-                  </a:txBody>
-                  <a:tcPr marL="91440" marR="91440">
-                    <a:solidFill>
-                      <a:srgbClr val="6A0505"/>
-                    </a:solidFill>
-                  </a:tcPr>
-                </a:tc>
-                <a:tc>
-                  <a:txBody>
-                    <a:bodyPr/>
-                    <a:lstStyle/>
-                    <a:p>
-                      <a:r>
-                        <a:rPr sz="2100" b="0">
-                          <a:solidFill>
-                            <a:srgbClr val="FFFFFF"/>
-                          </a:solidFill>
-                          <a:latin typeface="ITC Avant Garde Gothic"/>
-                        </a:rPr>
-                        <a:t>Aerodrome / port standards</a:t>
-                      </a:r>
-                    </a:p>
-                  </a:txBody>
-                  <a:tcPr marL="91440" marR="91440">
-                    <a:solidFill>
-                      <a:srgbClr val="6A0505"/>
-                    </a:solidFill>
-                  </a:tcPr>
-                </a:tc>
-                <a:tc>
-                  <a:txBody>
-                    <a:bodyPr/>
-                    <a:lstStyle/>
-                    <a:p>
-                      <a:r>
-                        <a:rPr sz="2100" b="0">
-                          <a:solidFill>
-                            <a:srgbClr val="FFFFFF"/>
-                          </a:solidFill>
-                          <a:latin typeface="ITC Avant Garde Gothic"/>
-                        </a:rPr>
-                        <a:t>Runway, pier rules</a:t>
-                      </a:r>
-                    </a:p>
-                  </a:txBody>
-                  <a:tcPr marL="91440" marR="91440">
-                    <a:solidFill>
-                      <a:srgbClr val="6A0505"/>
-                    </a:solidFill>
-                  </a:tcPr>
-                </a:tc>
-                <a:tc>
-                  <a:txBody>
-                    <a:bodyPr/>
-                    <a:lstStyle/>
-                    <a:p>
-                      <a:r>
-                        <a:rPr sz="2100" b="0">
-                          <a:solidFill>
-                            <a:srgbClr val="FFFFFF"/>
-                          </a:solidFill>
-                          <a:latin typeface="ITC Avant Garde Gothic"/>
-                        </a:rPr>
-                        <a:t>Not priced</a:t>
-                      </a:r>
-                    </a:p>
-                  </a:txBody>
-                  <a:tcPr marL="91440" marR="91440">
-                    <a:solidFill>
-                      <a:srgbClr val="6A0505"/>
                     </a:solidFill>
                   </a:tcPr>
                 </a:tc>
@@ -12472,7 +12382,7 @@
                 <a:cs typeface="ITC Avant Garde Gothic"/>
                 <a:sym typeface="ITC Avant Garde Gothic"/>
               </a:rPr>
-              <a:t>QUESTIONS &amp; ANSWER</a:t>
+              <a:t>Q &amp; A</a:t>
             </a:r>
           </a:p>
         </p:txBody>

</xml_diff>